<commit_message>
docs: refine Slide 5 to Google Gemini 2.5 Flash JSON Schema so presentation matches active engine
</commit_message>
<xml_diff>
--- a/PC-FIT_2학기_발표자료_최종.pptx
+++ b/PC-FIT_2학기_발표자료_최종.pptx
@@ -7725,7 +7725,7 @@
                 <a:ea typeface="맑은 고딕" pitchFamily="34" charset="-122"/>
                 <a:cs typeface="맑은 고딕" pitchFamily="34" charset="-120"/>
               </a:rPr>
-              <a:t>[멀티 AI 모델 연동]</a:t>
+              <a:t>[Google Gemini AI 엔진]</a:t>
             </a:r>
             <a:endParaRPr lang="en-US" sz="1050" dirty="0"/>
           </a:p>
@@ -7742,7 +7742,7 @@
                 <a:ea typeface="맑은 고딕" pitchFamily="34" charset="-122"/>
                 <a:cs typeface="맑은 고딕" pitchFamily="34" charset="-120"/>
               </a:rPr>
-              <a:t>Gemini 2.5 / 3.5 Flash</a:t>
+              <a:t>Gemini 2.5 Flash 기반</a:t>
             </a:r>
             <a:endParaRPr lang="en-US" sz="1050" dirty="0"/>
           </a:p>
@@ -7759,7 +7759,7 @@
                 <a:ea typeface="맑은 고딕" pitchFamily="34" charset="-122"/>
                 <a:cs typeface="맑은 고딕" pitchFamily="34" charset="-120"/>
               </a:rPr>
-              <a:t>GPT-5.1</a:t>
+              <a:t>정형 JSON 스키마 응답</a:t>
             </a:r>
             <a:endParaRPr lang="en-US" sz="1050" dirty="0"/>
           </a:p>
@@ -7776,24 +7776,7 @@
                 <a:ea typeface="맑은 고딕" pitchFamily="34" charset="-122"/>
                 <a:cs typeface="맑은 고딕" pitchFamily="34" charset="-120"/>
               </a:rPr>
-              <a:t>Claude Sonnet 4.6</a:t>
-            </a:r>
-            <a:endParaRPr lang="en-US" sz="1050" dirty="0"/>
-          </a:p>
-          <a:p>
-            <a:pPr algn="ctr" indent="0" marL="0">
-              <a:buNone/>
-            </a:pPr>
-            <a:r>
-              <a:rPr lang="en-US" sz="1050" b="1" dirty="0">
-                <a:solidFill>
-                  <a:srgbClr val="F8FAFC"/>
-                </a:solidFill>
-                <a:latin typeface="맑은 고딕" pitchFamily="34" charset="0"/>
-                <a:ea typeface="맑은 고딕" pitchFamily="34" charset="-122"/>
-                <a:cs typeface="맑은 고딕" pitchFamily="34" charset="-120"/>
-              </a:rPr>
-              <a:t>(장애 시 다음 모델로 자동 전환)</a:t>
+              <a:t>(verdict · chartData · tableData)</a:t>
             </a:r>
             <a:endParaRPr lang="en-US" sz="1050" dirty="0"/>
           </a:p>

</xml_diff>